<commit_message>
Emphasize vector database in condensed PowerPoint
- Updated add_cost_slide() to match full version's orange callout box
- Cost slide now leads with 'THE ARCHITECTURAL DIFFERENCE' title (28pt)
- Prominent explanation of vector database indexing vs recalculation
- Side-by-side Copilot (teal) vs OpenRouter (gray) comparison
- Vector database is THE key differentiator explaining 208x cost advantage
- Speaker notes updated with critical talking points
</commit_message>
<xml_diff>
--- a/presentation-internal.pptx
+++ b/presentation-internal.pptx
@@ -794,42 +794,52 @@
           <a:lstStyle/>
           <a:p>
             <a:r>
-              <a:t>Cost model deep-dive:</a:t>
-            </a:r>
-          </a:p>
-          <a:p>
-            <a:r>
-              <a:t>- We tested both toolchains on identical scenarios</a:t>
-            </a:r>
-          </a:p>
-          <a:p>
-            <a:r>
-              <a:t>- GitHub Copilot: $39/month fixed subscription - unlimited context, unlimited autonomous tool calls</a:t>
-            </a:r>
-          </a:p>
-          <a:p>
-            <a:r>
-              <a:t>- Intent-based billing: only human-typed prompts count (3x multiplier for Claude Opus 4.6)</a:t>
-            </a:r>
-          </a:p>
-          <a:p>
-            <a:r>
-              <a:t>- OpenRouter: pay per token for EVERYTHING - context recalculated from scratch every time</a:t>
-            </a:r>
-          </a:p>
-          <a:p>
-            <a:r>
-              <a:t>- 208x difference comes from architectural approach, not just pricing model</a:t>
-            </a:r>
-          </a:p>
-          <a:p>
-            <a:r>
-              <a:t>- As our workspace grows (more ADRs, more designs), Copilot cost stays flat, OpenRouter scales linearly</a:t>
-            </a:r>
-          </a:p>
-          <a:p>
-            <a:r>
-              <a:t>- This is a structural advantage, not a temporary pricing anomaly</a:t>
+              <a:t>CRITICAL TALKING POINT - Vector Database Advantage:</a:t>
+            </a:r>
+          </a:p>
+          <a:p>
+            <a:r>
+              <a:t>- This is THE most important slide - explains why 208x difference exists</a:t>
+            </a:r>
+          </a:p>
+          <a:p>
+            <a:r>
+              <a:t>- GitHub Copilot: Pre-indexes our workspace into a vector database (semantic search index)</a:t>
+            </a:r>
+          </a:p>
+          <a:p>
+            <a:r>
+              <a:t>- Indexing happens once, used unlimited times - amortized across fixed subscription</a:t>
+            </a:r>
+          </a:p>
+          <a:p>
+            <a:r>
+              <a:t>- OpenRouter: No indexing. Recalculates entire context from scratch every request, pays per token</a:t>
+            </a:r>
+          </a:p>
+          <a:p>
+            <a:r>
+              <a:t>- Intent-based billing: In Copilot, only human-typed prompts count. All autonomous tool calls are free.</a:t>
+            </a:r>
+          </a:p>
+          <a:p>
+            <a:r>
+              <a:t>- As our workspace grows (more ADRs, more designs), Copilot cost stays $39/month flat</a:t>
+            </a:r>
+          </a:p>
+          <a:p>
+            <a:r>
+              <a:t>- OpenRouter cost scales linearly with workspace size - bigger context = higher per-run cost</a:t>
+            </a:r>
+          </a:p>
+          <a:p>
+            <a:r>
+              <a:t>- This is a structural architectural advantage, not a temporary pricing difference</a:t>
+            </a:r>
+          </a:p>
+          <a:p>
+            <a:r>
+              <a:t>- Vector database is how Copilot achieves both low cost AND high accuracy</a:t>
             </a:r>
           </a:p>
         </p:txBody>
@@ -5191,28 +5201,73 @@
           <a:lstStyle/>
           <a:p>
             <a:pPr>
-              <a:defRPr sz="4000" b="1">
+              <a:defRPr sz="3800" b="1">
                 <a:solidFill>
                   <a:srgbClr val="37474F"/>
                 </a:solidFill>
               </a:defRPr>
             </a:pPr>
             <a:r>
-              <a:t>Cost Evidence: 208x Advantage</a:t>
-            </a:r>
-          </a:p>
-        </p:txBody>
-      </p:sp>
-      <p:sp>
-        <p:nvSpPr>
-          <p:cNvPr id="3" name="TextBox 2"/>
+              <a:t>Cost Evidence: The Vector Database Advantage</a:t>
+            </a:r>
+          </a:p>
+        </p:txBody>
+      </p:sp>
+      <p:sp>
+        <p:nvSpPr>
+          <p:cNvPr id="3" name="Rectangle 2"/>
+          <p:cNvSpPr/>
+          <p:nvPr/>
+        </p:nvSpPr>
+        <p:spPr>
+          <a:xfrm>
+            <a:off x="457200" y="1005840"/>
+            <a:ext cx="8229600" cy="2011680"/>
+          </a:xfrm>
+          <a:prstGeom prst="rect">
+            <a:avLst/>
+          </a:prstGeom>
+          <a:solidFill>
+            <a:srgbClr val="FF8F00"/>
+          </a:solidFill>
+          <a:ln w="38100">
+            <a:solidFill>
+              <a:srgbClr val="37474F"/>
+            </a:solidFill>
+          </a:ln>
+        </p:spPr>
+        <p:style>
+          <a:lnRef idx="1">
+            <a:schemeClr val="accent1"/>
+          </a:lnRef>
+          <a:fillRef idx="3">
+            <a:schemeClr val="accent1"/>
+          </a:fillRef>
+          <a:effectRef idx="2">
+            <a:schemeClr val="accent1"/>
+          </a:effectRef>
+          <a:fontRef idx="minor">
+            <a:schemeClr val="lt1"/>
+          </a:fontRef>
+        </p:style>
+        <p:txBody>
+          <a:bodyPr rtlCol="0" anchor="ctr"/>
+          <a:lstStyle/>
+          <a:p>
+            <a:pPr algn="ctr"/>
+          </a:p>
+        </p:txBody>
+      </p:sp>
+      <p:sp>
+        <p:nvSpPr>
+          <p:cNvPr id="4" name="TextBox 3"/>
           <p:cNvSpPr txBox="1"/>
           <p:nvPr/>
         </p:nvSpPr>
         <p:spPr>
           <a:xfrm>
-            <a:off x="457200" y="1097280"/>
-            <a:ext cx="3657600" cy="1371600"/>
+            <a:off x="640080" y="1188720"/>
+            <a:ext cx="7863840" cy="457200"/>
           </a:xfrm>
           <a:prstGeom prst="rect">
             <a:avLst/>
@@ -5226,196 +5281,295 @@
           <a:lstStyle/>
           <a:p>
             <a:pPr algn="ctr">
-              <a:defRPr sz="9600" b="1">
+              <a:defRPr sz="2800" b="1">
+                <a:solidFill>
+                  <a:srgbClr val="FFFFFF"/>
+                </a:solidFill>
+              </a:defRPr>
+            </a:pPr>
+            <a:r>
+              <a:t>THE ARCHITECTURAL DIFFERENCE</a:t>
+            </a:r>
+          </a:p>
+        </p:txBody>
+      </p:sp>
+      <p:sp>
+        <p:nvSpPr>
+          <p:cNvPr id="5" name="TextBox 4"/>
+          <p:cNvSpPr txBox="1"/>
+          <p:nvPr/>
+        </p:nvSpPr>
+        <p:spPr>
+          <a:xfrm>
+            <a:off x="640080" y="1737360"/>
+            <a:ext cx="7863840" cy="1097280"/>
+          </a:xfrm>
+          <a:prstGeom prst="rect">
+            <a:avLst/>
+          </a:prstGeom>
+          <a:noFill/>
+        </p:spPr>
+        <p:txBody>
+          <a:bodyPr wrap="square">
+            <a:spAutoFit/>
+          </a:bodyPr>
+          <a:lstStyle/>
+          <a:p>
+            <a:pPr algn="ctr">
+              <a:lnSpc>
+                <a:spcPct val="130000"/>
+              </a:lnSpc>
+              <a:defRPr sz="1600">
+                <a:solidFill>
+                  <a:srgbClr val="FFFFFF"/>
+                </a:solidFill>
+              </a:defRPr>
+            </a:pPr>
+            <a:r>
+              <a:t>GitHub Copilot pre-indexes our entire workspace into a VECTOR DATABASE. All our specs, diagrams, previous designs, domain knowledge - indexed once, used unlimited times. This is amortized across our fixed $39/month subscription.</a:t>
+            </a:r>
+          </a:p>
+          <a:p/>
+          <a:p>
+            <a:r>
+              <a:t>OpenRouter recalculates everything from scratch on every request. Pays per token, every time.</a:t>
+            </a:r>
+          </a:p>
+        </p:txBody>
+      </p:sp>
+      <p:sp>
+        <p:nvSpPr>
+          <p:cNvPr id="6" name="TextBox 5"/>
+          <p:cNvSpPr txBox="1"/>
+          <p:nvPr/>
+        </p:nvSpPr>
+        <p:spPr>
+          <a:xfrm>
+            <a:off x="457200" y="3383280"/>
+            <a:ext cx="3931920" cy="2560320"/>
+          </a:xfrm>
+          <a:prstGeom prst="rect">
+            <a:avLst/>
+          </a:prstGeom>
+          <a:noFill/>
+        </p:spPr>
+        <p:txBody>
+          <a:bodyPr wrap="square">
+            <a:spAutoFit/>
+          </a:bodyPr>
+          <a:lstStyle/>
+          <a:p>
+            <a:pPr>
+              <a:defRPr sz="2200" b="1">
+                <a:solidFill>
+                  <a:srgbClr val="00897B"/>
+                </a:solidFill>
+              </a:defRPr>
+            </a:pPr>
+            <a:r>
+              <a:t>GitHub Copilot Pro+</a:t>
+            </a:r>
+          </a:p>
+          <a:p>
+            <a:pPr>
+              <a:spcBef>
+                <a:spcPts val="800"/>
+              </a:spcBef>
+              <a:defRPr sz="1800" b="1"/>
+            </a:pPr>
+            <a:r>
+              <a:t>$39/month fixed subscription</a:t>
+            </a:r>
+          </a:p>
+          <a:p>
+            <a:pPr>
+              <a:spcBef>
+                <a:spcPts val="400"/>
+              </a:spcBef>
+              <a:defRPr sz="1300"/>
+            </a:pPr>
+            <a:r>
+              <a:t>✓ Vector database indexes workspace once</a:t>
+            </a:r>
+          </a:p>
+          <a:p>
+            <a:pPr>
+              <a:spcBef>
+                <a:spcPts val="400"/>
+              </a:spcBef>
+              <a:defRPr sz="1300"/>
+            </a:pPr>
+            <a:r>
+              <a:t>✓ Richer context costs nothing extra</a:t>
+            </a:r>
+          </a:p>
+          <a:p>
+            <a:pPr>
+              <a:spcBef>
+                <a:spcPts val="400"/>
+              </a:spcBef>
+              <a:defRPr sz="1300"/>
+            </a:pPr>
+            <a:r>
+              <a:t>✓ Intent-based billing: only human prompts count</a:t>
+            </a:r>
+          </a:p>
+          <a:p>
+            <a:pPr>
+              <a:spcBef>
+                <a:spcPts val="400"/>
+              </a:spcBef>
+              <a:defRPr sz="1300"/>
+            </a:pPr>
+            <a:r>
+              <a:t>✓ Autonomous tool calls are FREE</a:t>
+            </a:r>
+          </a:p>
+          <a:p>
+            <a:pPr>
+              <a:spcBef>
+                <a:spcPts val="400"/>
+              </a:spcBef>
+              <a:defRPr sz="1300"/>
+            </a:pPr>
+            <a:r>
+              <a:t>✓ As workspace grows, cost stays flat</a:t>
+            </a:r>
+          </a:p>
+        </p:txBody>
+      </p:sp>
+      <p:sp>
+        <p:nvSpPr>
+          <p:cNvPr id="7" name="TextBox 6"/>
+          <p:cNvSpPr txBox="1"/>
+          <p:nvPr/>
+        </p:nvSpPr>
+        <p:spPr>
+          <a:xfrm>
+            <a:off x="4754880" y="3383280"/>
+            <a:ext cx="3931920" cy="2560320"/>
+          </a:xfrm>
+          <a:prstGeom prst="rect">
+            <a:avLst/>
+          </a:prstGeom>
+          <a:noFill/>
+        </p:spPr>
+        <p:txBody>
+          <a:bodyPr wrap="square">
+            <a:spAutoFit/>
+          </a:bodyPr>
+          <a:lstStyle/>
+          <a:p>
+            <a:pPr>
+              <a:defRPr sz="2200" b="1">
+                <a:solidFill>
+                  <a:srgbClr val="969696"/>
+                </a:solidFill>
+              </a:defRPr>
+            </a:pPr>
+            <a:r>
+              <a:t>OpenRouter (Per-Token)</a:t>
+            </a:r>
+          </a:p>
+          <a:p>
+            <a:pPr>
+              <a:spcBef>
+                <a:spcPts val="800"/>
+              </a:spcBef>
+              <a:defRPr sz="1800" b="1"/>
+            </a:pPr>
+            <a:r>
+              <a:t>$155.73 per run (variable)</a:t>
+            </a:r>
+          </a:p>
+          <a:p>
+            <a:pPr>
+              <a:spcBef>
+                <a:spcPts val="400"/>
+              </a:spcBef>
+              <a:defRPr sz="1300"/>
+            </a:pPr>
+            <a:r>
+              <a:t>✗ Recalculates context every request</a:t>
+            </a:r>
+          </a:p>
+          <a:p>
+            <a:pPr>
+              <a:spcBef>
+                <a:spcPts val="400"/>
+              </a:spcBef>
+              <a:defRPr sz="1300"/>
+            </a:pPr>
+            <a:r>
+              <a:t>✗ Pays for every token, every time</a:t>
+            </a:r>
+          </a:p>
+          <a:p>
+            <a:pPr>
+              <a:spcBef>
+                <a:spcPts val="400"/>
+              </a:spcBef>
+              <a:defRPr sz="1300"/>
+            </a:pPr>
+            <a:r>
+              <a:t>✗ No indexing - starts from scratch</a:t>
+            </a:r>
+          </a:p>
+          <a:p>
+            <a:pPr>
+              <a:spcBef>
+                <a:spcPts val="400"/>
+              </a:spcBef>
+              <a:defRPr sz="1300"/>
+            </a:pPr>
+            <a:r>
+              <a:t>✗ Context size = direct cost</a:t>
+            </a:r>
+          </a:p>
+          <a:p>
+            <a:pPr>
+              <a:spcBef>
+                <a:spcPts val="400"/>
+              </a:spcBef>
+              <a:defRPr sz="1300"/>
+            </a:pPr>
+            <a:r>
+              <a:t>✗ As workspace grows, cost scales linearly</a:t>
+            </a:r>
+          </a:p>
+        </p:txBody>
+      </p:sp>
+      <p:sp>
+        <p:nvSpPr>
+          <p:cNvPr id="8" name="TextBox 7"/>
+          <p:cNvSpPr txBox="1"/>
+          <p:nvPr/>
+        </p:nvSpPr>
+        <p:spPr>
+          <a:xfrm>
+            <a:off x="457200" y="6126480"/>
+            <a:ext cx="8229600" cy="548640"/>
+          </a:xfrm>
+          <a:prstGeom prst="rect">
+            <a:avLst/>
+          </a:prstGeom>
+          <a:noFill/>
+        </p:spPr>
+        <p:txBody>
+          <a:bodyPr wrap="none">
+            <a:spAutoFit/>
+          </a:bodyPr>
+          <a:lstStyle/>
+          <a:p>
+            <a:pPr algn="ctr">
+              <a:defRPr sz="2000" b="1">
                 <a:solidFill>
                   <a:srgbClr val="FF8F00"/>
                 </a:solidFill>
               </a:defRPr>
             </a:pPr>
             <a:r>
-              <a:t>208x</a:t>
-            </a:r>
-          </a:p>
-        </p:txBody>
-      </p:sp>
-      <p:sp>
-        <p:nvSpPr>
-          <p:cNvPr id="4" name="TextBox 3"/>
-          <p:cNvSpPr txBox="1"/>
-          <p:nvPr/>
-        </p:nvSpPr>
-        <p:spPr>
-          <a:xfrm>
-            <a:off x="457200" y="2468880"/>
-            <a:ext cx="3657600" cy="365760"/>
-          </a:xfrm>
-          <a:prstGeom prst="rect">
-            <a:avLst/>
-          </a:prstGeom>
-          <a:noFill/>
-        </p:spPr>
-        <p:txBody>
-          <a:bodyPr wrap="none">
-            <a:spAutoFit/>
-          </a:bodyPr>
-          <a:lstStyle/>
-          <a:p>
-            <a:pPr algn="ctr">
-              <a:defRPr sz="2000"/>
-            </a:pPr>
-            <a:r>
-              <a:t>cheaper per run</a:t>
-            </a:r>
-          </a:p>
-        </p:txBody>
-      </p:sp>
-      <p:sp>
-        <p:nvSpPr>
-          <p:cNvPr id="5" name="TextBox 4"/>
-          <p:cNvSpPr txBox="1"/>
-          <p:nvPr/>
-        </p:nvSpPr>
-        <p:spPr>
-          <a:xfrm>
-            <a:off x="4572000" y="1097280"/>
-            <a:ext cx="4114800" cy="2286000"/>
-          </a:xfrm>
-          <a:prstGeom prst="rect">
-            <a:avLst/>
-          </a:prstGeom>
-          <a:noFill/>
-        </p:spPr>
-        <p:txBody>
-          <a:bodyPr wrap="square">
-            <a:spAutoFit/>
-          </a:bodyPr>
-          <a:lstStyle/>
-          <a:p>
-            <a:pPr>
-              <a:defRPr sz="2000" b="1">
-                <a:solidFill>
-                  <a:srgbClr val="00897B"/>
-                </a:solidFill>
-              </a:defRPr>
-            </a:pPr>
-            <a:r>
-              <a:t>The Architectural Difference:</a:t>
-            </a:r>
-          </a:p>
-          <a:p>
-            <a:pPr>
-              <a:spcBef>
-                <a:spcPts val="1200"/>
-              </a:spcBef>
-              <a:defRPr sz="1600" b="1"/>
-            </a:pPr>
-            <a:r>
-              <a:t>GitHub Copilot</a:t>
-            </a:r>
-          </a:p>
-          <a:p>
-            <a:pPr lvl="1">
-              <a:defRPr sz="1400"/>
-            </a:pPr>
-            <a:r>
-              <a:t>Pre-indexes workspace in vector database. Amortized across fixed subscription. Richer context costs nothing extra.</a:t>
-            </a:r>
-          </a:p>
-          <a:p>
-            <a:pPr>
-              <a:spcBef>
-                <a:spcPts val="1200"/>
-              </a:spcBef>
-              <a:defRPr sz="1600" b="1"/>
-            </a:pPr>
-            <a:r>
-              <a:t>OpenRouter (per-token billing)</a:t>
-            </a:r>
-          </a:p>
-          <a:p>
-            <a:pPr lvl="1">
-              <a:defRPr sz="1400"/>
-            </a:pPr>
-            <a:r>
-              <a:t>Recalculates entire context from scratch every request. Pays for every token, every time.</a:t>
-            </a:r>
-          </a:p>
-        </p:txBody>
-      </p:sp>
-      <p:sp>
-        <p:nvSpPr>
-          <p:cNvPr id="6" name="TextBox 5"/>
-          <p:cNvSpPr txBox="1"/>
-          <p:nvPr/>
-        </p:nvSpPr>
-        <p:spPr>
-          <a:xfrm>
-            <a:off x="457200" y="3474720"/>
-            <a:ext cx="8229600" cy="2560320"/>
-          </a:xfrm>
-          <a:prstGeom prst="rect">
-            <a:avLst/>
-          </a:prstGeom>
-          <a:noFill/>
-        </p:spPr>
-        <p:txBody>
-          <a:bodyPr wrap="square">
-            <a:spAutoFit/>
-          </a:bodyPr>
-          <a:lstStyle/>
-          <a:p>
-            <a:pPr>
-              <a:spcBef>
-                <a:spcPts val="1200"/>
-              </a:spcBef>
-              <a:defRPr sz="1800" b="1"/>
-            </a:pPr>
-            <a:r>
-              <a:t>5 Architecture Scenarios:</a:t>
-            </a:r>
-          </a:p>
-          <a:p>
-            <a:pPr>
-              <a:spcBef>
-                <a:spcPts val="600"/>
-              </a:spcBef>
-              <a:defRPr sz="1400"/>
-            </a:pPr>
-            <a:r>
-              <a:t>• GitHub Copilot: $39/month subscription (fixed)</a:t>
-            </a:r>
-          </a:p>
-          <a:p>
-            <a:pPr>
-              <a:spcBef>
-                <a:spcPts val="600"/>
-              </a:spcBef>
-              <a:defRPr sz="1400"/>
-            </a:pPr>
-            <a:r>
-              <a:t>• OpenRouter: $155.73 per run (variable, scales with context size)</a:t>
-            </a:r>
-          </a:p>
-          <a:p>
-            <a:pPr>
-              <a:spcBef>
-                <a:spcPts val="600"/>
-              </a:spcBef>
-              <a:defRPr sz="1400"/>
-            </a:pPr>
-            <a:r>
-              <a:t>• Total workspace: 19 services, 11 ADRs, 500+ lines of domain knowledge</a:t>
-            </a:r>
-          </a:p>
-          <a:p>
-            <a:pPr>
-              <a:spcBef>
-                <a:spcPts val="600"/>
-              </a:spcBef>
-              <a:defRPr sz="1400"/>
-            </a:pPr>
-            <a:r>
-              <a:t>• Intent-based billing: Only human prompts count, autonomous tool calls are free</a:t>
+              <a:t>Result: 208x cost advantage per run, and the gap widens as our workspace grows</a:t>
             </a:r>
           </a:p>
         </p:txBody>

</xml_diff>